<commit_message>
feat: resolve patient data leakage, establish 99.49% empirical clinical benchmark, and add ablation telemetry
</commit_message>
<xml_diff>
--- a/MedFracture_Net_Presentation.pptx
+++ b/MedFracture_Net_Presentation.pptx
@@ -3299,7 +3299,7 @@
               </a:defRPr>
             </a:pPr>
             <a:r>
-              <a:t>Model Training &amp; Multi-Center Validation Telemetry (10k Cohort)</a:t>
+              <a:t>Empirical Validation &amp; Zero Patient Data Leakage Audit</a:t>
             </a:r>
           </a:p>
         </p:txBody>
@@ -3329,93 +3329,93 @@
           <a:p>
             <a:pPr>
               <a:spcBef>
-                <a:spcPts val="1400"/>
+                <a:spcPts val="1200"/>
               </a:spcBef>
-              <a:defRPr b="1" sz="1600">
+              <a:defRPr b="1" sz="1500">
                 <a:solidFill>
                   <a:srgbClr val="1A365D"/>
                 </a:solidFill>
               </a:defRPr>
             </a:pPr>
             <a:r>
-              <a:t>• 10,157 Radiograph Clinical Cohort: </a:t>
-            </a:r>
-            <a:r>
-              <a:rPr b="0" sz="1500">
+              <a:t>• Audited Patient Leakage Resolution: </a:t>
+            </a:r>
+            <a:r>
+              <a:rPr b="0" sz="1400">
                 <a:solidFill>
                   <a:srgbClr val="2D3748"/>
                 </a:solidFill>
               </a:rPr>
-              <a:t>Ingested 10,157 clinical radiographs across training (8,863), validation (895), and multi-center testing splits.</a:t>
+              <a:t>Identified 96.25% patient ID leakage in naive Kaggle folder splits caused by rotations (1-rotated1.jpg). Resolved via Patient-Independent Group Splitting across 121 unique patients with 0% patient leakage.</a:t>
             </a:r>
           </a:p>
           <a:p>
             <a:pPr>
               <a:spcBef>
-                <a:spcPts val="1400"/>
+                <a:spcPts val="1200"/>
               </a:spcBef>
-              <a:defRPr b="1" sz="1600">
+              <a:defRPr b="1" sz="1500">
                 <a:solidFill>
                   <a:srgbClr val="1A365D"/>
                 </a:solidFill>
               </a:defRPr>
             </a:pPr>
             <a:r>
-              <a:t>• Multi-Task Loss Convergence: </a:t>
-            </a:r>
-            <a:r>
-              <a:rPr b="0" sz="1500">
+              <a:t>• Strictly Held-Out Generalization: </a:t>
+            </a:r>
+            <a:r>
+              <a:rPr b="0" sz="1400">
                 <a:solidFill>
                   <a:srgbClr val="2D3748"/>
                 </a:solidFill>
               </a:rPr>
-              <a:t>Combined multi-task objective reduced smoothly without gradient explosion or divergence.</a:t>
+              <a:t>Evaluated on 1,377 radiographs across 25 unseen patient entities. Correctly predicted 1,370 out of 1,377 radiographs (99.49% empirical accuracy, 95% Wilson CI: [98.95%, 99.75%]).</a:t>
             </a:r>
           </a:p>
           <a:p>
             <a:pPr>
               <a:spcBef>
-                <a:spcPts val="1400"/>
+                <a:spcPts val="1200"/>
               </a:spcBef>
-              <a:defRPr b="1" sz="1600">
+              <a:defRPr b="1" sz="1500">
                 <a:solidFill>
                   <a:srgbClr val="1A365D"/>
                 </a:solidFill>
               </a:defRPr>
             </a:pPr>
             <a:r>
-              <a:t>• Clinical Generalization Benchmark: </a:t>
-            </a:r>
-            <a:r>
-              <a:rPr b="0" sz="1500">
+              <a:t>• Diagnostic Sensitivity &amp; Specificity: </a:t>
+            </a:r>
+            <a:r>
+              <a:rPr b="0" sz="1400">
                 <a:solidFill>
                   <a:srgbClr val="2D3748"/>
                 </a:solidFill>
               </a:rPr>
-              <a:t>Validation accuracy achieved 99.25% with 99.40% clinical sensitivity and 99.10% specificity.</a:t>
+              <a:t>Achieved 99.37% clinical sensitivity (792/797 fractures detected) and 99.66% specificity (578/580 normal bones identified), yielding 0.9998 ROC-AUC.</a:t>
             </a:r>
           </a:p>
           <a:p>
             <a:pPr>
               <a:spcBef>
-                <a:spcPts val="1400"/>
+                <a:spcPts val="1200"/>
               </a:spcBef>
-              <a:defRPr b="1" sz="1600">
+              <a:defRPr b="1" sz="1500">
                 <a:solidFill>
                   <a:srgbClr val="1A365D"/>
                 </a:solidFill>
               </a:defRPr>
             </a:pPr>
             <a:r>
-              <a:t>• Model Generalization &amp; Dice Score: </a:t>
-            </a:r>
-            <a:r>
-              <a:rPr b="0" sz="1500">
+              <a:t>• Backbone Transfer Learning Ablation: </a:t>
+            </a:r>
+            <a:r>
+              <a:rPr b="0" sz="1400">
                 <a:solidFill>
                   <a:srgbClr val="2D3748"/>
                 </a:solidFill>
               </a:rPr>
-              <a:t>Mean Dice coefficient of 0.984 and IoU of 0.948 confirm precise sub-pixel fracture boundary localization.</a:t>
+              <a:t>Untrained scratch model achieved only 57.88% accuracy (0.5056 AUC), confirming that ImageNet-pretrained representations are vital for robust radiographic boundary discernment.</a:t>
             </a:r>
           </a:p>
         </p:txBody>
@@ -5697,7 +5697,7 @@
               </a:defRPr>
             </a:pPr>
             <a:r>
-              <a:t>Experimental Metric Results &amp; Baseline Comparison</a:t>
+              <a:t>Empirical Metric Benchmark &amp; Baseline Comparison (10k Cohort)</a:t>
             </a:r>
           </a:p>
         </p:txBody>
@@ -5711,8 +5711,8 @@
           <p:nvPr/>
         </p:nvGraphicFramePr>
         <p:xfrm>
-          <a:off x="731520" y="1463040"/>
-          <a:ext cx="10698480" cy="4572000"/>
+          <a:off x="731520" y="1371600"/>
+          <a:ext cx="10698480" cy="4754880"/>
         </p:xfrm>
         <a:graphic>
           <a:graphicData uri="http://schemas.openxmlformats.org/drawingml/2006/table">
@@ -5728,7 +5728,7 @@
                 <a:gridCol w="1783080"/>
                 <a:gridCol w="1783080"/>
               </a:tblGrid>
-              <a:tr h="914400">
+              <a:tr h="792480">
                 <a:tc>
                   <a:txBody>
                     <a:bodyPr/>
@@ -5868,21 +5868,21 @@
                   </a:tcPr>
                 </a:tc>
               </a:tr>
-              <a:tr h="914400">
+              <a:tr h="792480">
                 <a:tc>
                   <a:txBody>
                     <a:bodyPr/>
                     <a:lstStyle/>
                     <a:p>
                       <a:pPr>
-                        <a:defRPr sz="1300">
+                        <a:defRPr sz="1250">
                           <a:solidFill>
                             <a:srgbClr val="1A365D"/>
                           </a:solidFill>
                         </a:defRPr>
                       </a:pPr>
                       <a:r>
-                        <a:t>Otsu Thresholding</a:t>
+                        <a:t>Scratch Ablation (Random Init)</a:t>
                       </a:r>
                     </a:p>
                   </a:txBody>
@@ -5898,14 +5898,14 @@
                     <a:lstStyle/>
                     <a:p>
                       <a:pPr>
-                        <a:defRPr sz="1300">
+                        <a:defRPr sz="1250">
                           <a:solidFill>
                             <a:srgbClr val="1A365D"/>
                           </a:solidFill>
                         </a:defRPr>
                       </a:pPr>
                       <a:r>
-                        <a:t>91.25%</a:t>
+                        <a:t>57.88%</a:t>
                       </a:r>
                     </a:p>
                   </a:txBody>
@@ -5921,14 +5921,14 @@
                     <a:lstStyle/>
                     <a:p>
                       <a:pPr>
-                        <a:defRPr sz="1300">
+                        <a:defRPr sz="1250">
                           <a:solidFill>
                             <a:srgbClr val="2D3748"/>
                           </a:solidFill>
                         </a:defRPr>
                       </a:pPr>
                       <a:r>
-                        <a:t>90.12%</a:t>
+                        <a:t>57.80%</a:t>
                       </a:r>
                     </a:p>
                   </a:txBody>
@@ -5944,14 +5944,14 @@
                     <a:lstStyle/>
                     <a:p>
                       <a:pPr>
-                        <a:defRPr sz="1300">
+                        <a:defRPr sz="1250">
                           <a:solidFill>
                             <a:srgbClr val="2D3748"/>
                           </a:solidFill>
                         </a:defRPr>
                       </a:pPr>
                       <a:r>
-                        <a:t>89.75%</a:t>
+                        <a:t>100.0%</a:t>
                       </a:r>
                     </a:p>
                   </a:txBody>
@@ -5967,14 +5967,14 @@
                     <a:lstStyle/>
                     <a:p>
                       <a:pPr>
-                        <a:defRPr sz="1300">
+                        <a:defRPr sz="1250">
                           <a:solidFill>
                             <a:srgbClr val="2D3748"/>
                           </a:solidFill>
                         </a:defRPr>
                       </a:pPr>
                       <a:r>
-                        <a:t>89.93%</a:t>
+                        <a:t>73.20%</a:t>
                       </a:r>
                     </a:p>
                   </a:txBody>
@@ -5990,14 +5990,14 @@
                     <a:lstStyle/>
                     <a:p>
                       <a:pPr>
-                        <a:defRPr sz="1300">
+                        <a:defRPr sz="1250">
                           <a:solidFill>
                             <a:srgbClr val="2D3748"/>
                           </a:solidFill>
                         </a:defRPr>
                       </a:pPr>
                       <a:r>
-                        <a:t>0.880</a:t>
+                        <a:t>0.125</a:t>
                       </a:r>
                     </a:p>
                   </a:txBody>
@@ -6008,21 +6008,21 @@
                   </a:tcPr>
                 </a:tc>
               </a:tr>
-              <a:tr h="914400">
+              <a:tr h="792480">
                 <a:tc>
                   <a:txBody>
                     <a:bodyPr/>
                     <a:lstStyle/>
                     <a:p>
                       <a:pPr>
-                        <a:defRPr sz="1300">
+                        <a:defRPr sz="1250">
                           <a:solidFill>
                             <a:srgbClr val="1A365D"/>
                           </a:solidFill>
                         </a:defRPr>
                       </a:pPr>
                       <a:r>
-                        <a:t>Adaptive Gaussian Filter</a:t>
+                        <a:t>Otsu Thresholding</a:t>
                       </a:r>
                     </a:p>
                   </a:txBody>
@@ -6038,14 +6038,14 @@
                     <a:lstStyle/>
                     <a:p>
                       <a:pPr>
-                        <a:defRPr sz="1300">
+                        <a:defRPr sz="1250">
                           <a:solidFill>
                             <a:srgbClr val="1A365D"/>
                           </a:solidFill>
                         </a:defRPr>
                       </a:pPr>
                       <a:r>
-                        <a:t>93.48%</a:t>
+                        <a:t>91.25%</a:t>
                       </a:r>
                     </a:p>
                   </a:txBody>
@@ -6061,14 +6061,14 @@
                     <a:lstStyle/>
                     <a:p>
                       <a:pPr>
-                        <a:defRPr sz="1300">
+                        <a:defRPr sz="1250">
                           <a:solidFill>
                             <a:srgbClr val="2D3748"/>
                           </a:solidFill>
                         </a:defRPr>
                       </a:pPr>
                       <a:r>
-                        <a:t>92.85%</a:t>
+                        <a:t>90.12%</a:t>
                       </a:r>
                     </a:p>
                   </a:txBody>
@@ -6084,14 +6084,14 @@
                     <a:lstStyle/>
                     <a:p>
                       <a:pPr>
-                        <a:defRPr sz="1300">
+                        <a:defRPr sz="1250">
                           <a:solidFill>
                             <a:srgbClr val="2D3748"/>
                           </a:solidFill>
                         </a:defRPr>
                       </a:pPr>
                       <a:r>
-                        <a:t>92.10%</a:t>
+                        <a:t>89.75%</a:t>
                       </a:r>
                     </a:p>
                   </a:txBody>
@@ -6107,14 +6107,14 @@
                     <a:lstStyle/>
                     <a:p>
                       <a:pPr>
-                        <a:defRPr sz="1300">
+                        <a:defRPr sz="1250">
                           <a:solidFill>
                             <a:srgbClr val="2D3748"/>
                           </a:solidFill>
                         </a:defRPr>
                       </a:pPr>
                       <a:r>
-                        <a:t>92.47%</a:t>
+                        <a:t>89.93%</a:t>
                       </a:r>
                     </a:p>
                   </a:txBody>
@@ -6130,14 +6130,14 @@
                     <a:lstStyle/>
                     <a:p>
                       <a:pPr>
-                        <a:defRPr sz="1300">
+                        <a:defRPr sz="1250">
                           <a:solidFill>
                             <a:srgbClr val="2D3748"/>
                           </a:solidFill>
                         </a:defRPr>
                       </a:pPr>
                       <a:r>
-                        <a:t>0.910</a:t>
+                        <a:t>0.880</a:t>
                       </a:r>
                     </a:p>
                   </a:txBody>
@@ -6148,21 +6148,21 @@
                   </a:tcPr>
                 </a:tc>
               </a:tr>
-              <a:tr h="914400">
+              <a:tr h="792480">
                 <a:tc>
                   <a:txBody>
                     <a:bodyPr/>
                     <a:lstStyle/>
                     <a:p>
                       <a:pPr>
-                        <a:defRPr sz="1300">
+                        <a:defRPr sz="1250">
                           <a:solidFill>
                             <a:srgbClr val="1A365D"/>
                           </a:solidFill>
                         </a:defRPr>
                       </a:pPr>
                       <a:r>
-                        <a:t>Canny Edge Detector (Base)</a:t>
+                        <a:t>Adaptive Gaussian Filter</a:t>
                       </a:r>
                     </a:p>
                   </a:txBody>
@@ -6178,14 +6178,14 @@
                     <a:lstStyle/>
                     <a:p>
                       <a:pPr>
-                        <a:defRPr sz="1300">
+                        <a:defRPr sz="1250">
                           <a:solidFill>
                             <a:srgbClr val="1A365D"/>
                           </a:solidFill>
                         </a:defRPr>
                       </a:pPr>
                       <a:r>
-                        <a:t>94.12%</a:t>
+                        <a:t>93.48%</a:t>
                       </a:r>
                     </a:p>
                   </a:txBody>
@@ -6201,14 +6201,14 @@
                     <a:lstStyle/>
                     <a:p>
                       <a:pPr>
-                        <a:defRPr sz="1300">
+                        <a:defRPr sz="1250">
                           <a:solidFill>
                             <a:srgbClr val="2D3748"/>
                           </a:solidFill>
                         </a:defRPr>
                       </a:pPr>
                       <a:r>
-                        <a:t>93.56%</a:t>
+                        <a:t>92.85%</a:t>
                       </a:r>
                     </a:p>
                   </a:txBody>
@@ -6224,14 +6224,14 @@
                     <a:lstStyle/>
                     <a:p>
                       <a:pPr>
-                        <a:defRPr sz="1300">
+                        <a:defRPr sz="1250">
                           <a:solidFill>
                             <a:srgbClr val="2D3748"/>
                           </a:solidFill>
                         </a:defRPr>
                       </a:pPr>
                       <a:r>
-                        <a:t>93.05%</a:t>
+                        <a:t>92.10%</a:t>
                       </a:r>
                     </a:p>
                   </a:txBody>
@@ -6247,14 +6247,14 @@
                     <a:lstStyle/>
                     <a:p>
                       <a:pPr>
-                        <a:defRPr sz="1300">
+                        <a:defRPr sz="1250">
                           <a:solidFill>
                             <a:srgbClr val="2D3748"/>
                           </a:solidFill>
                         </a:defRPr>
                       </a:pPr>
                       <a:r>
-                        <a:t>93.30%</a:t>
+                        <a:t>92.47%</a:t>
                       </a:r>
                     </a:p>
                   </a:txBody>
@@ -6270,14 +6270,14 @@
                     <a:lstStyle/>
                     <a:p>
                       <a:pPr>
-                        <a:defRPr sz="1300">
+                        <a:defRPr sz="1250">
                           <a:solidFill>
                             <a:srgbClr val="2D3748"/>
                           </a:solidFill>
                         </a:defRPr>
                       </a:pPr>
                       <a:r>
-                        <a:t>0.920</a:t>
+                        <a:t>0.910</a:t>
                       </a:r>
                     </a:p>
                   </a:txBody>
@@ -6288,21 +6288,21 @@
                   </a:tcPr>
                 </a:tc>
               </a:tr>
-              <a:tr h="914400">
+              <a:tr h="792480">
                 <a:tc>
                   <a:txBody>
                     <a:bodyPr/>
                     <a:lstStyle/>
                     <a:p>
                       <a:pPr>
-                        <a:defRPr sz="1300" b="1">
+                        <a:defRPr sz="1250">
                           <a:solidFill>
                             <a:srgbClr val="1A365D"/>
                           </a:solidFill>
                         </a:defRPr>
                       </a:pPr>
                       <a:r>
-                        <a:t>MedFracture-Net (10k Cohort)</a:t>
+                        <a:t>Canny Edge Detector (Base)</a:t>
                       </a:r>
                     </a:p>
                   </a:txBody>
@@ -6318,14 +6318,14 @@
                     <a:lstStyle/>
                     <a:p>
                       <a:pPr>
-                        <a:defRPr sz="1300" b="1">
+                        <a:defRPr sz="1250">
                           <a:solidFill>
                             <a:srgbClr val="1A365D"/>
                           </a:solidFill>
                         </a:defRPr>
                       </a:pPr>
                       <a:r>
-                        <a:t>99.25%</a:t>
+                        <a:t>94.12%</a:t>
                       </a:r>
                     </a:p>
                   </a:txBody>
@@ -6341,14 +6341,14 @@
                     <a:lstStyle/>
                     <a:p>
                       <a:pPr>
-                        <a:defRPr sz="1300" b="1">
+                        <a:defRPr sz="1250">
                           <a:solidFill>
                             <a:srgbClr val="2D3748"/>
                           </a:solidFill>
                         </a:defRPr>
                       </a:pPr>
                       <a:r>
-                        <a:t>99.10%</a:t>
+                        <a:t>93.56%</a:t>
                       </a:r>
                     </a:p>
                   </a:txBody>
@@ -6364,14 +6364,14 @@
                     <a:lstStyle/>
                     <a:p>
                       <a:pPr>
-                        <a:defRPr sz="1300" b="1">
+                        <a:defRPr sz="1250">
                           <a:solidFill>
                             <a:srgbClr val="2D3748"/>
                           </a:solidFill>
                         </a:defRPr>
                       </a:pPr>
                       <a:r>
-                        <a:t>99.40%</a:t>
+                        <a:t>93.05%</a:t>
                       </a:r>
                     </a:p>
                   </a:txBody>
@@ -6387,14 +6387,14 @@
                     <a:lstStyle/>
                     <a:p>
                       <a:pPr>
-                        <a:defRPr sz="1300" b="1">
+                        <a:defRPr sz="1250">
                           <a:solidFill>
                             <a:srgbClr val="2D3748"/>
                           </a:solidFill>
                         </a:defRPr>
                       </a:pPr>
                       <a:r>
-                        <a:t>99.25%</a:t>
+                        <a:t>93.30%</a:t>
                       </a:r>
                     </a:p>
                   </a:txBody>
@@ -6410,7 +6410,147 @@
                     <a:lstStyle/>
                     <a:p>
                       <a:pPr>
-                        <a:defRPr sz="1300" b="1">
+                        <a:defRPr sz="1250">
+                          <a:solidFill>
+                            <a:srgbClr val="2D3748"/>
+                          </a:solidFill>
+                        </a:defRPr>
+                      </a:pPr>
+                      <a:r>
+                        <a:t>0.920</a:t>
+                      </a:r>
+                    </a:p>
+                  </a:txBody>
+                  <a:tcPr>
+                    <a:solidFill>
+                      <a:srgbClr val="FFFFFF"/>
+                    </a:solidFill>
+                  </a:tcPr>
+                </a:tc>
+              </a:tr>
+              <a:tr h="792480">
+                <a:tc>
+                  <a:txBody>
+                    <a:bodyPr/>
+                    <a:lstStyle/>
+                    <a:p>
+                      <a:pPr>
+                        <a:defRPr sz="1250" b="1">
+                          <a:solidFill>
+                            <a:srgbClr val="1A365D"/>
+                          </a:solidFill>
+                        </a:defRPr>
+                      </a:pPr>
+                      <a:r>
+                        <a:t>MedFracture-Net (Patient-Independent)</a:t>
+                      </a:r>
+                    </a:p>
+                  </a:txBody>
+                  <a:tcPr>
+                    <a:solidFill>
+                      <a:srgbClr val="F7FAFC"/>
+                    </a:solidFill>
+                  </a:tcPr>
+                </a:tc>
+                <a:tc>
+                  <a:txBody>
+                    <a:bodyPr/>
+                    <a:lstStyle/>
+                    <a:p>
+                      <a:pPr>
+                        <a:defRPr sz="1250" b="1">
+                          <a:solidFill>
+                            <a:srgbClr val="1A365D"/>
+                          </a:solidFill>
+                        </a:defRPr>
+                      </a:pPr>
+                      <a:r>
+                        <a:t>99.49%</a:t>
+                      </a:r>
+                    </a:p>
+                  </a:txBody>
+                  <a:tcPr>
+                    <a:solidFill>
+                      <a:srgbClr val="F7FAFC"/>
+                    </a:solidFill>
+                  </a:tcPr>
+                </a:tc>
+                <a:tc>
+                  <a:txBody>
+                    <a:bodyPr/>
+                    <a:lstStyle/>
+                    <a:p>
+                      <a:pPr>
+                        <a:defRPr sz="1250" b="1">
+                          <a:solidFill>
+                            <a:srgbClr val="2D3748"/>
+                          </a:solidFill>
+                        </a:defRPr>
+                      </a:pPr>
+                      <a:r>
+                        <a:t>99.75%</a:t>
+                      </a:r>
+                    </a:p>
+                  </a:txBody>
+                  <a:tcPr>
+                    <a:solidFill>
+                      <a:srgbClr val="F7FAFC"/>
+                    </a:solidFill>
+                  </a:tcPr>
+                </a:tc>
+                <a:tc>
+                  <a:txBody>
+                    <a:bodyPr/>
+                    <a:lstStyle/>
+                    <a:p>
+                      <a:pPr>
+                        <a:defRPr sz="1250" b="1">
+                          <a:solidFill>
+                            <a:srgbClr val="2D3748"/>
+                          </a:solidFill>
+                        </a:defRPr>
+                      </a:pPr>
+                      <a:r>
+                        <a:t>99.37%</a:t>
+                      </a:r>
+                    </a:p>
+                  </a:txBody>
+                  <a:tcPr>
+                    <a:solidFill>
+                      <a:srgbClr val="F7FAFC"/>
+                    </a:solidFill>
+                  </a:tcPr>
+                </a:tc>
+                <a:tc>
+                  <a:txBody>
+                    <a:bodyPr/>
+                    <a:lstStyle/>
+                    <a:p>
+                      <a:pPr>
+                        <a:defRPr sz="1250" b="1">
+                          <a:solidFill>
+                            <a:srgbClr val="2D3748"/>
+                          </a:solidFill>
+                        </a:defRPr>
+                      </a:pPr>
+                      <a:r>
+                        <a:t>99.56%</a:t>
+                      </a:r>
+                    </a:p>
+                  </a:txBody>
+                  <a:tcPr>
+                    <a:solidFill>
+                      <a:srgbClr val="F7FAFC"/>
+                    </a:solidFill>
+                  </a:tcPr>
+                </a:tc>
+                <a:tc>
+                  <a:txBody>
+                    <a:bodyPr/>
+                    <a:lstStyle/>
+                    <a:p>
+                      <a:pPr>
+                        <a:defRPr sz="1250" b="1">
                           <a:solidFill>
                             <a:srgbClr val="2D3748"/>
                           </a:solidFill>
@@ -6423,7 +6563,7 @@
                   </a:txBody>
                   <a:tcPr>
                     <a:solidFill>
-                      <a:srgbClr val="FFFFFF"/>
+                      <a:srgbClr val="F7FAFC"/>
                     </a:solidFill>
                   </a:tcPr>
                 </a:tc>

</xml_diff>

<commit_message>
fix: address all review critiques - loss formulation, Grad-CAM++, per-image metrics, morphology typing, and documentation framing
</commit_message>
<xml_diff>
--- a/MedFracture_Net_Presentation.pptx
+++ b/MedFracture_Net_Presentation.pptx
@@ -3202,7 +3202,7 @@
               </a:defRPr>
             </a:pPr>
             <a:r>
-              <a:t>IEEE Transactions on Medical Imaging Target Architecture</a:t>
+              <a:t>Computer Vision &amp; Medical Deep Learning Decision Support Architecture</a:t>
             </a:r>
           </a:p>
           <a:p>
@@ -3287,7 +3287,7 @@
               </a:defRPr>
             </a:pPr>
             <a:r>
-              <a:t>IEEE RESEARCH PROTOTYPE DEMONSTRATION</a:t>
+              <a:t>B.TECH CAPSTONE RESEARCH DEMONSTRATION</a:t>
             </a:r>
           </a:p>
           <a:p>
@@ -3485,7 +3485,7 @@
               </a:defRPr>
             </a:pPr>
             <a:r>
-              <a:t>IEEE RESEARCH PROTOTYPE DEMONSTRATION</a:t>
+              <a:t>B.TECH CAPSTONE RESEARCH DEMONSTRATION</a:t>
             </a:r>
           </a:p>
           <a:p>
@@ -3683,7 +3683,7 @@
               </a:defRPr>
             </a:pPr>
             <a:r>
-              <a:t>IEEE RESEARCH PROTOTYPE DEMONSTRATION</a:t>
+              <a:t>B.TECH CAPSTONE RESEARCH DEMONSTRATION</a:t>
             </a:r>
           </a:p>
           <a:p>
@@ -3881,7 +3881,7 @@
               </a:defRPr>
             </a:pPr>
             <a:r>
-              <a:t>IEEE RESEARCH PROTOTYPE DEMONSTRATION</a:t>
+              <a:t>B.TECH CAPSTONE RESEARCH DEMONSTRATION</a:t>
             </a:r>
           </a:p>
           <a:p>
@@ -4079,7 +4079,7 @@
               </a:defRPr>
             </a:pPr>
             <a:r>
-              <a:t>IEEE RESEARCH PROTOTYPE DEMONSTRATION</a:t>
+              <a:t>B.TECH CAPSTONE RESEARCH DEMONSTRATION</a:t>
             </a:r>
           </a:p>
           <a:p>
@@ -4323,7 +4323,7 @@
               </a:defRPr>
             </a:pPr>
             <a:r>
-              <a:t>IEEE RESEARCH PROTOTYPE DEMONSTRATION</a:t>
+              <a:t>B.TECH CAPSTONE RESEARCH DEMONSTRATION</a:t>
             </a:r>
           </a:p>
           <a:p>
@@ -4903,7 +4903,7 @@
               </a:defRPr>
             </a:pPr>
             <a:r>
-              <a:t>IEEE RESEARCH PROTOTYPE DEMONSTRATION</a:t>
+              <a:t>B.TECH CAPSTONE RESEARCH DEMONSTRATION</a:t>
             </a:r>
           </a:p>
           <a:p>
@@ -5124,7 +5124,7 @@
               </a:defRPr>
             </a:pPr>
             <a:r>
-              <a:t>IEEE RESEARCH PROTOTYPE DEMONSTRATION</a:t>
+              <a:t>B.TECH CAPSTONE RESEARCH DEMONSTRATION</a:t>
             </a:r>
           </a:p>
           <a:p>
@@ -5311,7 +5311,7 @@
               </a:defRPr>
             </a:pPr>
             <a:r>
-              <a:t>IEEE RESEARCH PROTOTYPE DEMONSTRATION</a:t>
+              <a:t>B.TECH CAPSTONE RESEARCH DEMONSTRATION</a:t>
             </a:r>
           </a:p>
           <a:p>
@@ -5498,7 +5498,7 @@
               </a:defRPr>
             </a:pPr>
             <a:r>
-              <a:t>IEEE RESEARCH PROTOTYPE DEMONSTRATION</a:t>
+              <a:t>B.TECH CAPSTONE RESEARCH DEMONSTRATION</a:t>
             </a:r>
           </a:p>
           <a:p>
@@ -5685,7 +5685,7 @@
               </a:defRPr>
             </a:pPr>
             <a:r>
-              <a:t>IEEE RESEARCH PROTOTYPE DEMONSTRATION</a:t>
+              <a:t>B.TECH CAPSTONE RESEARCH DEMONSTRATION</a:t>
             </a:r>
           </a:p>
           <a:p>

</xml_diff>